<commit_message>
Additional pictures for the paper and project presentation
</commit_message>
<xml_diff>
--- a/20260611_EXP02_vs_EXP03_OlgaZaitseva_1.pptx
+++ b/20260611_EXP02_vs_EXP03_OlgaZaitseva_1.pptx
@@ -6,10 +6,10 @@
     <p:sldMasterId id="2147483703" r:id="rId2"/>
   </p:sldMasterIdLst>
   <p:notesMasterIdLst>
-    <p:notesMasterId r:id="rId20"/>
+    <p:notesMasterId r:id="rId19"/>
   </p:notesMasterIdLst>
   <p:handoutMasterIdLst>
-    <p:handoutMasterId r:id="rId21"/>
+    <p:handoutMasterId r:id="rId20"/>
   </p:handoutMasterIdLst>
   <p:sldIdLst>
     <p:sldId id="290" r:id="rId3"/>
@@ -28,7 +28,6 @@
     <p:sldId id="505" r:id="rId16"/>
     <p:sldId id="507" r:id="rId17"/>
     <p:sldId id="508" r:id="rId18"/>
-    <p:sldId id="497" r:id="rId19"/>
   </p:sldIdLst>
   <p:sldSz cx="9144000" cy="5143500" type="screen16x9"/>
   <p:notesSz cx="6797675" cy="9874250"/>
@@ -4783,14 +4782,14 @@
           </a:ln>
           <a:extLst>
             <a:ext uri="{909E8E84-426E-40dd-AFC4-6F175D3DCCD1}">
-              <a14:hiddenFill xmlns="" xmlns:a14="http://schemas.microsoft.com/office/drawing/2010/main">
+              <a14:hiddenFill xmlns:a14="http://schemas.microsoft.com/office/drawing/2010/main" xmlns="">
                 <a:solidFill>
                   <a:srgbClr val="FFFFFF"/>
                 </a:solidFill>
               </a14:hiddenFill>
             </a:ext>
             <a:ext uri="{91240B29-F687-4f45-9708-019B960494DF}">
-              <a14:hiddenLine xmlns="" xmlns:a14="http://schemas.microsoft.com/office/drawing/2010/main" w="9525">
+              <a14:hiddenLine xmlns:a14="http://schemas.microsoft.com/office/drawing/2010/main" xmlns="" w="9525">
                 <a:solidFill>
                   <a:srgbClr val="000000"/>
                 </a:solidFill>
@@ -4800,7 +4799,7 @@
               </a14:hiddenLine>
             </a:ext>
             <a:ext uri="{FAA26D3D-D897-4be2-8F04-BA451C77F1D7}">
-              <ma14:placeholderFlag xmlns="" xmlns:ma14="http://schemas.microsoft.com/office/mac/drawingml/2011/main" val="1"/>
+              <ma14:placeholderFlag xmlns:ma14="http://schemas.microsoft.com/office/mac/drawingml/2011/main" xmlns="" val="1"/>
             </a:ext>
           </a:extLst>
         </p:spPr>
@@ -4845,14 +4844,14 @@
           </a:ln>
           <a:extLst>
             <a:ext uri="{909E8E84-426E-40dd-AFC4-6F175D3DCCD1}">
-              <a14:hiddenFill xmlns="" xmlns:a14="http://schemas.microsoft.com/office/drawing/2010/main">
+              <a14:hiddenFill xmlns:a14="http://schemas.microsoft.com/office/drawing/2010/main" xmlns="">
                 <a:solidFill>
                   <a:srgbClr val="FFFFFF"/>
                 </a:solidFill>
               </a14:hiddenFill>
             </a:ext>
             <a:ext uri="{91240B29-F687-4f45-9708-019B960494DF}">
-              <a14:hiddenLine xmlns="" xmlns:a14="http://schemas.microsoft.com/office/drawing/2010/main" w="9525">
+              <a14:hiddenLine xmlns:a14="http://schemas.microsoft.com/office/drawing/2010/main" xmlns="" w="9525">
                 <a:solidFill>
                   <a:srgbClr val="000000"/>
                 </a:solidFill>
@@ -4862,7 +4861,7 @@
               </a14:hiddenLine>
             </a:ext>
             <a:ext uri="{FAA26D3D-D897-4be2-8F04-BA451C77F1D7}">
-              <ma14:placeholderFlag xmlns="" xmlns:ma14="http://schemas.microsoft.com/office/mac/drawingml/2011/main" val="1"/>
+              <ma14:placeholderFlag xmlns:ma14="http://schemas.microsoft.com/office/mac/drawingml/2011/main" xmlns="" val="1"/>
             </a:ext>
           </a:extLst>
         </p:spPr>
@@ -5050,14 +5049,14 @@
             </a:ln>
             <a:extLst>
               <a:ext uri="{909E8E84-426E-40dd-AFC4-6F175D3DCCD1}">
-                <a14:hiddenFill xmlns="" xmlns:a14="http://schemas.microsoft.com/office/drawing/2010/main">
+                <a14:hiddenFill xmlns:a14="http://schemas.microsoft.com/office/drawing/2010/main" xmlns="">
                   <a:solidFill>
                     <a:srgbClr val="FFFFFF"/>
                   </a:solidFill>
                 </a14:hiddenFill>
               </a:ext>
               <a:ext uri="{91240B29-F687-4f45-9708-019B960494DF}">
-                <a14:hiddenLine xmlns="" xmlns:a14="http://schemas.microsoft.com/office/drawing/2010/main" w="9525">
+                <a14:hiddenLine xmlns:a14="http://schemas.microsoft.com/office/drawing/2010/main" xmlns="" w="9525">
                   <a:solidFill>
                     <a:srgbClr val="000000"/>
                   </a:solidFill>
@@ -5159,14 +5158,14 @@
             </a:ln>
             <a:extLst>
               <a:ext uri="{909E8E84-426E-40dd-AFC4-6F175D3DCCD1}">
-                <a14:hiddenFill xmlns="" xmlns:a14="http://schemas.microsoft.com/office/drawing/2010/main">
+                <a14:hiddenFill xmlns:a14="http://schemas.microsoft.com/office/drawing/2010/main" xmlns="">
                   <a:solidFill>
                     <a:srgbClr val="FFFFFF"/>
                   </a:solidFill>
                 </a14:hiddenFill>
               </a:ext>
               <a:ext uri="{91240B29-F687-4f45-9708-019B960494DF}">
-                <a14:hiddenLine xmlns="" xmlns:a14="http://schemas.microsoft.com/office/drawing/2010/main" w="9525">
+                <a14:hiddenLine xmlns:a14="http://schemas.microsoft.com/office/drawing/2010/main" xmlns="" w="9525">
                   <a:solidFill>
                     <a:srgbClr val="000000"/>
                   </a:solidFill>
@@ -5229,14 +5228,14 @@
               </a:ln>
               <a:extLst>
                 <a:ext uri="{909E8E84-426E-40dd-AFC4-6F175D3DCCD1}">
-                  <a14:hiddenFill xmlns="" xmlns:a14="http://schemas.microsoft.com/office/drawing/2010/main">
+                  <a14:hiddenFill xmlns:a14="http://schemas.microsoft.com/office/drawing/2010/main" xmlns="">
                     <a:solidFill>
                       <a:srgbClr val="FFFFFF"/>
                     </a:solidFill>
                   </a14:hiddenFill>
                 </a:ext>
                 <a:ext uri="{91240B29-F687-4f45-9708-019B960494DF}">
-                  <a14:hiddenLine xmlns="" xmlns:a14="http://schemas.microsoft.com/office/drawing/2010/main" w="9525">
+                  <a14:hiddenLine xmlns:a14="http://schemas.microsoft.com/office/drawing/2010/main" xmlns="" w="9525">
                     <a:solidFill>
                       <a:srgbClr val="000000"/>
                     </a:solidFill>
@@ -5270,14 +5269,14 @@
               </a:ln>
               <a:extLst>
                 <a:ext uri="{909E8E84-426E-40dd-AFC4-6F175D3DCCD1}">
-                  <a14:hiddenFill xmlns="" xmlns:a14="http://schemas.microsoft.com/office/drawing/2010/main">
+                  <a14:hiddenFill xmlns:a14="http://schemas.microsoft.com/office/drawing/2010/main" xmlns="">
                     <a:solidFill>
                       <a:srgbClr val="FFFFFF"/>
                     </a:solidFill>
                   </a14:hiddenFill>
                 </a:ext>
                 <a:ext uri="{91240B29-F687-4f45-9708-019B960494DF}">
-                  <a14:hiddenLine xmlns="" xmlns:a14="http://schemas.microsoft.com/office/drawing/2010/main" w="9525">
+                  <a14:hiddenLine xmlns:a14="http://schemas.microsoft.com/office/drawing/2010/main" xmlns="" w="9525">
                     <a:solidFill>
                       <a:srgbClr val="000000"/>
                     </a:solidFill>
@@ -7133,7 +7132,12 @@
             <p:ph idx="1"/>
           </p:nvPr>
         </p:nvSpPr>
-        <p:spPr/>
+        <p:spPr>
+          <a:xfrm>
+            <a:off x="382249" y="1116767"/>
+            <a:ext cx="8304551" cy="3534469"/>
+          </a:xfrm>
+        </p:spPr>
         <p:txBody>
           <a:bodyPr/>
           <a:lstStyle/>
@@ -7143,54 +7147,49 @@
               <a:buChar char="•"/>
             </a:pPr>
             <a:r>
-              <a:rPr lang="hr-HR" sz="1800" b="0" dirty="0" err="1"/>
+              <a:rPr lang="nl-NL" sz="1300" b="0" dirty="0"/>
+              <a:t>The </a:t>
+            </a:r>
+            <a:r>
+              <a:rPr lang="nl-NL" sz="1300" b="0" dirty="0" err="1"/>
+              <a:t>primary</a:t>
+            </a:r>
+            <a:r>
+              <a:rPr lang="nl-NL" sz="1300" b="0" dirty="0"/>
+              <a:t> driver of </a:t>
+            </a:r>
+            <a:r>
+              <a:rPr lang="hr-HR" sz="1300" b="0" dirty="0" err="1"/>
               <a:t>IgG</a:t>
             </a:r>
             <a:r>
-              <a:rPr lang="hr-HR" sz="1800" b="0" dirty="0"/>
+              <a:rPr lang="hr-HR" sz="1300" b="0" dirty="0"/>
               <a:t> </a:t>
             </a:r>
             <a:r>
-              <a:rPr lang="hr-HR" sz="1800" b="0" dirty="0" err="1"/>
+              <a:rPr lang="hr-HR" sz="1300" b="0" dirty="0" err="1"/>
               <a:t>Fc</a:t>
             </a:r>
             <a:r>
-              <a:rPr lang="hr-HR" sz="1800" b="0" dirty="0"/>
+              <a:rPr lang="hr-HR" sz="1300" b="0" dirty="0"/>
               <a:t> N</a:t>
             </a:r>
             <a:r>
-              <a:rPr lang="en-GB" sz="1800" b="0" dirty="0"/>
+              <a:rPr lang="en-GB" sz="1300" b="0" dirty="0"/>
               <a:t>-</a:t>
             </a:r>
             <a:r>
-              <a:rPr lang="en-GB" sz="1800" b="0" dirty="0" err="1"/>
+              <a:rPr lang="en-GB" sz="1300" b="0" dirty="0" err="1"/>
               <a:t>glycome</a:t>
             </a:r>
             <a:r>
-              <a:rPr lang="en-GB" sz="1800" b="0" dirty="0"/>
-              <a:t> composition is similar within </a:t>
-            </a:r>
-            <a:r>
-              <a:rPr lang="en-GB" sz="1800" b="0" dirty="0" err="1"/>
-              <a:t>IgGs</a:t>
-            </a:r>
-            <a:r>
-              <a:rPr lang="en-GB" sz="1800" b="0" dirty="0"/>
-              <a:t> with the same heavy chain but different light chains (WT and NO)</a:t>
-            </a:r>
-            <a:r>
-              <a:rPr lang="en-US" sz="1800" b="0" dirty="0"/>
-              <a:t> have an impact only on </a:t>
-            </a:r>
-            <a:r>
-              <a:rPr lang="en-US" sz="1800" b="0" dirty="0" err="1"/>
-              <a:t>agalactosylation</a:t>
-            </a:r>
-            <a:r>
-              <a:rPr lang="en-US" sz="1800" b="0" dirty="0"/>
-              <a:t> (NO&gt;WT) and high-mannose content (WT &gt; NO).</a:t>
-            </a:r>
-            <a:endParaRPr lang="ru-RU" sz="1800" b="0" dirty="0"/>
+              <a:rPr lang="en-GB" sz="1300" b="0" dirty="0"/>
+              <a:t> composition is the HC sequence with </a:t>
+            </a:r>
+            <a:r>
+              <a:rPr lang="en-HR" sz="1300" b="0" dirty="0"/>
+              <a:t>a significant HC main effect replicated across both experiments for 7 of 8 traits (except for monoantennary glycans).</a:t>
+            </a:r>
           </a:p>
           <a:p>
             <a:pPr marL="214313" indent="-214313">
@@ -7198,24 +7197,16 @@
               <a:buChar char="•"/>
             </a:pPr>
             <a:r>
-              <a:rPr lang="en-US" sz="1800" b="0" dirty="0"/>
-              <a:t>Bisection, antennary </a:t>
-            </a:r>
-            <a:r>
-              <a:rPr lang="en-US" sz="1800" b="0" dirty="0" err="1"/>
-              <a:t>fucosylation</a:t>
-            </a:r>
-            <a:r>
-              <a:rPr lang="en-US" sz="1800" b="0" dirty="0"/>
-              <a:t> and </a:t>
-            </a:r>
-            <a:r>
-              <a:rPr lang="en-US" sz="1800" b="0" dirty="0" err="1"/>
-              <a:t>galactosylation</a:t>
-            </a:r>
-            <a:r>
-              <a:rPr lang="en-US" sz="1800" b="0" dirty="0"/>
-              <a:t> are higher in IgG1_Y and IgG1_YF as compared to IgG1_YI and IgG1_YA in both experiments </a:t>
+              <a:rPr lang="en-HR" sz="1300" b="0" dirty="0"/>
+              <a:t>The effects of LC chain are limited and replicated</a:t>
+            </a:r>
+            <a:r>
+              <a:rPr lang="en-GB" sz="1300" b="0" dirty="0"/>
+              <a:t> only for </a:t>
+            </a:r>
+            <a:r>
+              <a:rPr lang="en-HR" sz="1300" b="0" dirty="0"/>
+              <a:t>agalactosylation (NO &gt; WT) and high-mannose content (WT &gt; NO).</a:t>
             </a:r>
           </a:p>
           <a:p>
@@ -7224,9 +7215,10 @@
               <a:buChar char="•"/>
             </a:pPr>
             <a:r>
-              <a:rPr lang="en-US" sz="1800" b="0" dirty="0"/>
-              <a:t>High mannose and hybrid structures are more abundant on IgG1_YA and IgG1_YI as compared to IgG1_YF and IgG1_Y</a:t>
-            </a:r>
+              <a:rPr lang="en-HR" sz="1300" b="0" dirty="0"/>
+              <a:t>No HC×LC interactions replicated between the experiments.</a:t>
+            </a:r>
+            <a:endParaRPr lang="ru-RU" sz="1300" b="0" dirty="0"/>
           </a:p>
           <a:p>
             <a:pPr marL="214313" indent="-214313">
@@ -7234,12 +7226,8 @@
               <a:buChar char="•"/>
             </a:pPr>
             <a:r>
-              <a:rPr lang="en-US" sz="1800" b="0" dirty="0" err="1"/>
-              <a:t>Agalactosylated</a:t>
-            </a:r>
-            <a:r>
-              <a:rPr lang="en-US" sz="1800" b="0" dirty="0"/>
-              <a:t> glycans are more abundant on YF and YA than on Y and YI in both experiments.</a:t>
+              <a:rPr lang="en-HR" sz="1300" b="0" dirty="0"/>
+              <a:t>Two groups of traits show opposite HC-dependent patterns. Galactosylation, sialylation, bisection, and antennary fucosylation are elevated in Y and YF relative to YA and YI in both experiments. High-mannose and hybrid structures show the reverse — elevated in YA and YI. Hierarchical clustering of antibody z-score profiles groups Y with YF and YA with YI in both experiments, reflecting this shared directionality.</a:t>
             </a:r>
           </a:p>
           <a:p>
@@ -7248,24 +7236,46 @@
               <a:buChar char="•"/>
             </a:pPr>
             <a:r>
-              <a:rPr lang="en-US" sz="1800" b="0" dirty="0"/>
-              <a:t>Levels of </a:t>
-            </a:r>
-            <a:r>
-              <a:rPr lang="en-US" sz="1800" b="0" dirty="0" err="1"/>
-              <a:t>agalactosylated</a:t>
-            </a:r>
-            <a:r>
-              <a:rPr lang="en-US" sz="1800" b="0" dirty="0"/>
-              <a:t> glycans and monoantennary structures were lower on IgG1_Y than on other heavy chain variants</a:t>
-            </a:r>
-            <a:endParaRPr lang="en-GB" sz="1800" b="0" dirty="0"/>
-          </a:p>
-          <a:p>
-            <a:pPr marL="0" indent="0">
-              <a:buNone/>
+              <a:rPr lang="en-HR" sz="1300" b="0" dirty="0"/>
+              <a:t>Agalactosylation peaks at YA, is second high in YF, further declines at YI and is lowest at Y. This pattern is not shared by any other structure.</a:t>
+            </a:r>
+          </a:p>
+          <a:p>
+            <a:pPr marL="214313" indent="-214313">
+              <a:buFont typeface="Arial" panose="020B0604020202020204" pitchFamily="34" charset="0"/>
+              <a:buChar char="•"/>
             </a:pPr>
-            <a:endParaRPr lang="en-GB" sz="1400" b="0" dirty="0"/>
+            <a:r>
+              <a:rPr lang="en-HR" sz="1300" b="0" dirty="0"/>
+              <a:t> Monoantennary structures show a significant HC effect in both experiments but with inconsistent direction at YI between experiments and are therefore not considered robustly replicated.</a:t>
+            </a:r>
+          </a:p>
+          <a:p>
+            <a:pPr marL="214313" indent="-214313">
+              <a:buFont typeface="Arial" panose="020B0604020202020204" pitchFamily="34" charset="0"/>
+              <a:buChar char="•"/>
+            </a:pPr>
+            <a:r>
+              <a:rPr lang="en-HR" sz="1300" b="0" dirty="0"/>
+              <a:t>For all antibodies, </a:t>
+            </a:r>
+            <a:r>
+              <a:rPr lang="en-US" sz="1300" b="0" dirty="0"/>
+              <a:t>the most abundant species are </a:t>
+            </a:r>
+            <a:r>
+              <a:rPr lang="en-US" sz="1300" b="0" dirty="0" err="1"/>
+              <a:t>asialylated</a:t>
+            </a:r>
+            <a:r>
+              <a:rPr lang="en-US" sz="1300" b="0" dirty="0"/>
+              <a:t> complex glycans dominated by H3N4F1 (FA2), H4N4F1 (FA2G1) and H3N3F1 (FA1). </a:t>
+            </a:r>
+            <a:r>
+              <a:rPr lang="en-HR" sz="1300" b="0" dirty="0"/>
+              <a:t>An increase in H3N3F1 is observed in EXP03 relative to EXP02 across all sample types.</a:t>
+            </a:r>
+            <a:endParaRPr lang="en-GB" sz="1300" b="0" dirty="0"/>
           </a:p>
         </p:txBody>
       </p:sp>
@@ -7273,119 +7283,6 @@
     <p:extLst>
       <p:ext uri="{BB962C8B-B14F-4D97-AF65-F5344CB8AC3E}">
         <p14:creationId xmlns:p14="http://schemas.microsoft.com/office/powerpoint/2010/main" val="1907928087"/>
-      </p:ext>
-    </p:extLst>
-  </p:cSld>
-  <p:clrMapOvr>
-    <a:masterClrMapping/>
-  </p:clrMapOvr>
-  <mc:AlternateContent xmlns:mc="http://schemas.openxmlformats.org/markup-compatibility/2006" xmlns:p14="http://schemas.microsoft.com/office/powerpoint/2010/main">
-    <mc:Choice Requires="p14">
-      <p:transition spd="med" p14:dur="700">
-        <p:fade/>
-      </p:transition>
-    </mc:Choice>
-    <mc:Fallback xmlns="">
-      <p:transition spd="med">
-        <p:fade/>
-      </p:transition>
-    </mc:Fallback>
-  </mc:AlternateContent>
-</p:sld>
-</file>
-
-<file path=ppt/slides/slide17.xml><?xml version="1.0" encoding="utf-8"?>
-<p:sld xmlns:a="http://schemas.openxmlformats.org/drawingml/2006/main" xmlns:r="http://schemas.openxmlformats.org/officeDocument/2006/relationships" xmlns:p="http://schemas.openxmlformats.org/presentationml/2006/main">
-  <p:cSld>
-    <p:spTree>
-      <p:nvGrpSpPr>
-        <p:cNvPr id="1" name=""/>
-        <p:cNvGrpSpPr/>
-        <p:nvPr/>
-      </p:nvGrpSpPr>
-      <p:grpSpPr>
-        <a:xfrm>
-          <a:off x="0" y="0"/>
-          <a:ext cx="0" cy="0"/>
-          <a:chOff x="0" y="0"/>
-          <a:chExt cx="0" cy="0"/>
-        </a:xfrm>
-      </p:grpSpPr>
-      <p:sp>
-        <p:nvSpPr>
-          <p:cNvPr id="2" name="Title 1">
-            <a:extLst>
-              <a:ext uri="{FF2B5EF4-FFF2-40B4-BE49-F238E27FC236}">
-                <a16:creationId xmlns:a16="http://schemas.microsoft.com/office/drawing/2014/main" id="{C38BED80-D999-8217-04F9-C92BA459EE9D}"/>
-              </a:ext>
-            </a:extLst>
-          </p:cNvPr>
-          <p:cNvSpPr>
-            <a:spLocks noGrp="1"/>
-          </p:cNvSpPr>
-          <p:nvPr>
-            <p:ph type="title"/>
-          </p:nvPr>
-        </p:nvSpPr>
-        <p:spPr/>
-        <p:txBody>
-          <a:bodyPr/>
-          <a:lstStyle/>
-          <a:p>
-            <a:r>
-              <a:rPr lang="en-US" dirty="0"/>
-              <a:t>Conclusions</a:t>
-            </a:r>
-          </a:p>
-        </p:txBody>
-      </p:sp>
-      <p:sp>
-        <p:nvSpPr>
-          <p:cNvPr id="3" name="Content Placeholder 2">
-            <a:extLst>
-              <a:ext uri="{FF2B5EF4-FFF2-40B4-BE49-F238E27FC236}">
-                <a16:creationId xmlns:a16="http://schemas.microsoft.com/office/drawing/2014/main" id="{6D47ED85-FF54-52FF-13D4-81AB5B9D4E35}"/>
-              </a:ext>
-            </a:extLst>
-          </p:cNvPr>
-          <p:cNvSpPr>
-            <a:spLocks noGrp="1"/>
-          </p:cNvSpPr>
-          <p:nvPr>
-            <p:ph idx="1"/>
-          </p:nvPr>
-        </p:nvSpPr>
-        <p:spPr/>
-        <p:txBody>
-          <a:bodyPr/>
-          <a:lstStyle/>
-          <a:p>
-            <a:r>
-              <a:rPr lang="en-US" sz="1800" b="0" dirty="0"/>
-              <a:t>Glycan profiles are broadly consistent between the two experiments. For all sample types, the most abundant species are </a:t>
-            </a:r>
-            <a:r>
-              <a:rPr lang="en-US" sz="1800" b="0" dirty="0" err="1"/>
-              <a:t>asialylated</a:t>
-            </a:r>
-            <a:r>
-              <a:rPr lang="en-US" sz="1800" b="0" dirty="0"/>
-              <a:t> complex glycans. Most abundant species for all sample types are H3N4F1 (FA2), H4N4F1 (FA2G1) and H3N3F1 (FA1)</a:t>
-            </a:r>
-            <a:endParaRPr lang="ru-RU" sz="1800" b="0" dirty="0"/>
-          </a:p>
-          <a:p>
-            <a:r>
-              <a:rPr lang="en-US" sz="1800" b="0" dirty="0"/>
-              <a:t>Differences: in all sample types there is an increase in truncated H3N3F1 structure in EXP03.</a:t>
-            </a:r>
-          </a:p>
-        </p:txBody>
-      </p:sp>
-    </p:spTree>
-    <p:extLst>
-      <p:ext uri="{BB962C8B-B14F-4D97-AF65-F5344CB8AC3E}">
-        <p14:creationId xmlns:p14="http://schemas.microsoft.com/office/powerpoint/2010/main" val="2243927447"/>
       </p:ext>
     </p:extLst>
   </p:cSld>

</xml_diff>